<commit_message>
Add package.json and package-lock.json for presentation module
- Created package.json to define the presentation module with dependencies and scripts.
- Added package-lock.json to lock the versions of dependencies used in the project.
</commit_message>
<xml_diff>
--- a/docs/presentation/SkyOps_Data_교육용_발표자료.pptx
+++ b/docs/presentation/SkyOps_Data_교육용_발표자료.pptx
@@ -531,8 +531,7 @@
           <a:p>
             <a:r>
               <a:rPr lang="en-US" dirty="0"/>
-              <a:t>안녕하세요. 오늘은 SkyOps Intelligence 프로젝트의 '데이터'에 집중해서 설명드립니다. 한국인 학생과 외국인 학생 모두 이해할 수 있도록 한글 설명 옆에 영어 핵심 용어를 병기했습니다. 총 30 장, 약 25~30 분 예상입니다.
-Hello. Today's session focuses on the DATA side of SkyOps Intelligence. Korean and English key terms are shown side-by-side. 30 slides, ~25-30 min.</a:t>
+              <a:t>안녕하세요. 빅데이터과 3 학년 정재원입니다. 오늘은 제가 속한 DoubleJ 팀이 만든 SkyOps Intelligence 프로젝트의 데이터 이야기를 해보려 합니다. 이 프로젝트에서 데이터가 어떻게 수집되고, 어떻게 가공되고, 최종적으로 모델이 되는지를 중심으로 설명드리겠습니다. 앞으로 30 장 동안, 여러분은 '원본 데이터 한 줄이 어떻게 관제사 화면의 알림 하나가 되는가' 라는 질문에 대한 답을 찾게 되실 겁니다.</a:t>
             </a:r>
             <a:endParaRPr lang="en-US" dirty="0"/>
           </a:p>
@@ -620,7 +619,7 @@
           <a:p>
             <a:r>
               <a:rPr lang="en-US" dirty="0"/>
-              <a:t>같은 데이터를 JSON 으로 100 B, CSV 로 60 B, Avro 로 35 B 에 담습니다. 초당 수천 건 오는 Kafka 에서는 이 차이가 누적되어 거대합니다. 그리고 무엇보다 Avro 는 스키마를 강제하기 때문에 장애가 줄어듭니다.</a:t>
+              <a:t>똑같은 항공기 위치 한 건이라도 JSON 으로는 100 바이트, CSV 로는 60 바이트, Avro 로는 35 바이트에 담을 수 있습니다. 초당 수천 건이 흐르는 Kafka 환경에서는 이 차이가 하루 누적 수십 기가바이트의 차이를 만듭니다. 하지만 제가 Avro 를 선택한 가장 큰 이유는 크기보다 스키마 강제이고, 다음 슬라이드에서 자세히 설명드립니다.</a:t>
             </a:r>
             <a:endParaRPr lang="en-US" dirty="0"/>
           </a:p>
@@ -708,7 +707,7 @@
           <a:p>
             <a:r>
               <a:rPr lang="en-US" dirty="0"/>
-              <a:t>Schema Registry 는 'producer 가 스키마를 바꿀 때 consumer 를 깨지 않도록' 강제하는 중앙 규칙 서버입니다. BACKWARD 호환 정책은 '새 consumer 가 옛 데이터도 읽을 수 있어야 한다' 는 뜻입니다. 덕분에 장애 시 롤백이 안전합니다.</a:t>
+              <a:t>스키마가 없으면 producer 가 새 필드를 추가했을 때 기존 consumer 가 옛 필드명을 기대하고 있기 때문에 KeyError 를 던지며 서비스가 다운됩니다. 그리고 누가 언제 무엇을 바꿨는지 아무도 답할 수 없습니다. Schema Registry 에 BACKWARD 호환 정책을 적용해 두면, 호환이 깨지는 변경은 배포 전에 409 Conflict 응답으로 거부됩니다. 호환되는 변경은 통과되고 기존 consumer 는 default 값으로 안전하게 동작합니다. BACKWARD 호환은 새 consumer 가 옛 데이터도 읽을 수 있어야 한다는 뜻이고, 덕분에 장애 상황에서 이전 버전으로 롤백하는 것이 안전해집니다.</a:t>
             </a:r>
             <a:endParaRPr lang="en-US" dirty="0"/>
           </a:p>
@@ -796,7 +795,7 @@
           <a:p>
             <a:r>
               <a:rPr lang="en-US" dirty="0"/>
-              <a:t>이 6 단계가 모든 ML 프로젝트의 기초입니다. 각 단계를 뛰어넘으면 반드시 나중에 문제가 생깁니다. 다음 슬라이드부터 각 단계를 하나씩 자세히 설명드리겠습니다.</a:t>
+              <a:t>모든 ML 프로젝트는 결국 여섯 단계를 거칩니다. Clean 으로 결측과 이상, 중복을 제거하고, Missing 으로 NaN 을 세 가지 전략으로 처리합니다. 그다음 Feature Engineering 으로 원본 값을 분해하고, Rotation Features 에서 도메인 지식을 주입해 R² 를 335 퍼센트 끌어올렸습니다. Split 에서 TimeSeriesSplit 으로 시간순 분할을 하고, 마지막 Iceberg 에서 Bronze, Silver, Gold 계층에 저장합니다. 왼쪽의 오백칠십만 행 raw 데이터가 오른쪽의 40만, 5만, 5만 행 model-ready 학습 세트로 변환되는 것이 이 여섯 단계 안에서 일어납니다.</a:t>
             </a:r>
             <a:endParaRPr lang="en-US" dirty="0"/>
           </a:p>
@@ -884,7 +883,7 @@
           <a:p>
             <a:r>
               <a:rPr lang="en-US" dirty="0"/>
-              <a:t>진짜 원본 데이터는 이렇게 지저분합니다. 'null', '-9999', 음수 거리 같은 sentinel 값, 중복 레코드 등. 이걸 모르고 바로 모델 학습 시키면 쓰레기 입력 → 쓰레기 출력 (GIGO) 이 됩니다.</a:t>
+              <a:t>진짜 원본 데이터가 얼마나 지저분한지 보여드립니다. 똑같은 레코드가 두 번 등장하는 중복이 있고, AIRLINE 필드가 비어 있고 DEP_DELAY 가 null 인 결측이 있으며, DEP_DELAY 값이 마이너스 구천구백구십구인 경우는 실제 지연이 아니라 센서 오류 마커인 sentinel value 입니다. DISTANCE 가 마이너스 일인 경우는 거리가 음수일 수 없으니 범위 오류로 처리해야 합니다. 중복은 drop_duplicates 로 제거하고, 결측은 세 전략으로 처리하며, sentinel 은 NaN 으로 치환하고, 범위는 필터로 잡아냅니다. 이 과정을 건너뛰고 바로 모델에 넣으면 GIGO, 즉 쓰레기를 넣으면 쓰레기가 나오는 현상이 발생합니다.</a:t>
             </a:r>
             <a:endParaRPr lang="en-US" dirty="0"/>
           </a:p>
@@ -972,7 +971,7 @@
           <a:p>
             <a:r>
               <a:rPr lang="en-US" dirty="0"/>
-              <a:t>XGBoost 가 인기 있는 이유 중 하나가 이겁니다 — 결측값을 그냥 받아줍니다. 다른 모델 (logistic regression, kNN 등) 은 NaN 이 있으면 아예 학습이 안 됩니다. 실무에서 이 편의성은 엄청난 시간 절약입니다.</a:t>
+              <a:t>결측값을 처리하는 방법에는 세 가지 전략이 있습니다. 첫 번째 Drop 은 그냥 버리는 방식이고, 두 번째 Impute 는 평균이나 중간값으로 채우는 방식이며, 세 번째 XGBoost Native 는 결측값을 분할 방향 자체로 학습하는 방식입니다. XGBoost 가 인기 있는 이유가 여기 있습니다. 로지스틱 회귀나 kNN 같은 다른 모델은 NaN 이 하나라도 있으면 아예 학습조차 안 됩니다. 저는 sklearn Pipeline 에 SimpleImputer 를 넣고 최종 estimator 로 XGBoost 를 두는 이중 안전망 구조를 쓰고 있습니다.</a:t>
             </a:r>
             <a:endParaRPr lang="en-US" dirty="0"/>
           </a:p>
@@ -1060,7 +1059,7 @@
           <a:p>
             <a:r>
               <a:rPr lang="en-US" dirty="0"/>
-              <a:t>가장 기본적인 feature engineering: 시간 분해. 모델은 '2026-04-19 14:30' 이라는 문자열을 아예 읽지 못합니다. hour=14, month=4, is_weekend=1 처럼 숫자로 나눠줘야 XGBoost 가 패턴을 찾습니다.</a:t>
+              <a:t>모델은 문자열을 읽지 못하고 오직 숫자만 이해할 수 있습니다. 2026-04-19 14:30:00 같은 datetime 문자열을 그대로 넣으면 모델이 아무 정보도 얻지 못합니다. hour 14, minute 30, dayofweek 6, month 4, dayofyear 109, is_weekend 1 처럼 여섯 개의 숫자 피처로 분해해야 모델이 주중과 주말의 차이, 월별 패턴, 시간대 패턴을 각각 독립적으로 볼 수 있습니다. 평일 18 시 혼잡도와 토요일 18 시 혼잡도가 다르고, 7 월과 8 월은 지연이 많으며, 오전 6 시는 정시인 반면 저녁 18 시는 지연이 누적됩니다. 이것이 Feature Engineering 의 출발점입니다.</a:t>
             </a:r>
             <a:endParaRPr lang="en-US" dirty="0"/>
           </a:p>
@@ -1148,7 +1147,7 @@
           <a:p>
             <a:r>
               <a:rPr lang="en-US" dirty="0"/>
-              <a:t>이 슬라이드가 이 발표에서 가장 중요한 교훈입니다. '모델을 더 크게' 가 아니라 '도메인 지식을 feature 로' 가 정답이었다는 것. 같은 XGBoost 에 피처 5 개만 더했을 뿐인데 Test R² 가 0.10 에서 0.43 으로 3.35 배 올랐습니다.</a:t>
+              <a:t>이 슬라이드는 이번 발표에서 가장 중요한 슬라이드입니다. Test R² 가 0.10 에서 0.43 으로 335 퍼센트 상승했는데, 같은 XGBoost 모델에 피처 다섯 개만 추가했을 뿐입니다. 핵심 아이디어는 같은 비행기가 하루에 세 번에서 다섯 번 뜨는데, 지연이 눈덩이처럼 누적된다는 점이었습니다. 예를 들어 HL8281 편은 06 시에는 2 분 지연, 09 시 5 분, 12 시 12 분, 15 시 24 분, 18 시에는 45 분까지 쌓입니다. EUROCONTROL 연구에 따르면 전체 지연의 45 퍼센트가 이런 reactionary 딜레이입니다. rotation_depth, prev_leg_arr_delay_min, scheduled_turnaround_min, actual_turnaround_min, is_first_leg_of_day 다섯 개 피처만으로 R² 가 3.35 배가 됐습니다. 교훈은 명확합니다. 모델을 키우는 것보다 도메인 지식을 피처로 만드는 것이 훨씬 효과적입니다.</a:t>
             </a:r>
             <a:endParaRPr lang="en-US" dirty="0"/>
           </a:p>
@@ -1236,7 +1235,7 @@
           <a:p>
             <a:r>
               <a:rPr lang="en-US" dirty="0"/>
-              <a:t>초심자가 가장 많이 하는 실수입니다. sklearn 의 train_test_split 은 기본값이 shuffle=True 라서 시계열 데이터에 그대로 쓰면 미래 정보가 과거 학습에 새어들어가 성능이 인위적으로 좋아 보입니다. ADR-004 에 이걸 원칙으로 못박고 전체 파이프라인을 수정했습니다.</a:t>
+              <a:t>두 번째로 중요한 교훈이자 초심자가 가장 많이 범하는 치명적인 실수입니다. sklearn 의 train_test_split 은 기본값이 shuffle True 라서 시간 축을 무시하고 무작위로 섞어 나눕니다. 그러면 미래가 과거 훈련에 섞여 들어가는 temporal leakage 가 발생하고, CV 표준편차가 플러스마이너스 0.30 으로 비정상적으로 작아 보이는 낙관적 편향이 생깁니다. TimeSeriesSplit 의 walk-forward 방식을 쓰면 과거로만 학습하고 미래로만 평가하게 됩니다. CV 표준편차가 플러스마이너스 6.14 로 20 배 증가하지만, 이것이 정직한 수치이고 시간대별 성능 변동성을 드러냅니다. 저는 이 원칙을 ADR-004 에 명시하고 파이프라인 전체를 수정했습니다. 여러분 코드에 shuffle True 가 시계열 데이터에 쓰이고 있다면 지금 당장 고치시기 바랍니다.</a:t>
             </a:r>
             <a:endParaRPr lang="en-US" dirty="0"/>
           </a:p>
@@ -1324,7 +1323,7 @@
           <a:p>
             <a:r>
               <a:rPr lang="en-US" dirty="0"/>
-              <a:t>Bronze 가 있어서 원본을 재해석할 수 있고, Silver 가 있어서 여러 모델이 같은 feature 를 공유하고, Gold 는 모델 소비 + 감사 추적용입니다. 사고 분석 시 '어느 레이어에서 틀어졌나' 를 layer-by-layer 로 추적 가능합니다.</a:t>
+              <a:t>전처리의 마지막 단계는 저장인데, 그냥 CSV 에 저장하면 안 됩니다. Apache Iceberg 의 Medallion 아키텍처를 Bronze, Silver, Gold 세 계층으로 나눠 쓰고 있습니다. Bronze 는 원본 그대로 저장해서 재처리 기준점이 되고, Silver 는 정제와 조인이 끝난 flight_features 같은 통합 테이블이며, Gold 는 모델이 직접 소비하는 inference_log 나 anomaly_decisions 같은 감사용 테이블입니다. 세 계층을 쓰는 이유는 ACID 트랜잭션으로 일관성을 유지하고, 스키마 진화를 지원하며, Time travel 로 '3 일 전 테이블 상태가 어땠지' 같은 사고 조사용 쿼리가 가능하기 때문입니다.</a:t>
             </a:r>
             <a:endParaRPr lang="en-US" dirty="0"/>
           </a:p>
@@ -1412,7 +1411,7 @@
           <a:p>
             <a:r>
               <a:rPr lang="en-US" dirty="0"/>
-              <a:t>같은 데이터 셋으로 만들 수 있는 프로젝트가 8 가지 이상 있습니다. 우리는 이 중 2 개 — 지연 예측과 이상 탐지 — 를 선택했습니다. 왜? 둘 다 관제사의 실제 의사결정에 직접 기여하기 때문입니다.</a:t>
+              <a:t>같은 데이터 셋으로 만들 수 있는 프로젝트가 최소 여덟 가지입니다. 지연 예측, 항공권 가격 예측, 공항 혼잡도 예측, 연료 소비 최적화, 운항 경로 최적화, 기상 영향 분석, 이상 탐지, 승객 수요 예측이 모두 가능합니다. 같은 데이터이지만 다른 질문, 다른 프로젝트가 만들어집니다. 여러분이 선택한 질문이 곧 여러분 프로젝트의 정체성을 결정합니다. 저는 이 여덟 가지 중에서 지연 예측과 이상 탐지 두 가지를 선택했습니다. 둘 다 관제사의 실시간 의사결정에 직접 기여하기 때문입니다.</a:t>
             </a:r>
             <a:endParaRPr lang="en-US" dirty="0"/>
           </a:p>
@@ -1500,8 +1499,7 @@
           <a:p>
             <a:r>
               <a:rPr lang="en-US" dirty="0"/>
-              <a:t>이 5 가지를 마지막까지 기억해 주세요. 특히 3 번 '시계열 분할' 과 4 번 'feature engineering 의 위력' 은 실제 우리 프로젝트의 P0 / P1 sprint 에서 증명된 사례입니다.
-Keep these 5 goals in mind. Points 3 (time-ordered split) and 4 (feature engineering power) were proven in our actual P0 / P1 sprints.</a:t>
+              <a:t>이 발표가 끝났을 때 여러분이 다섯 가지를 이해하시도록 구성했습니다. 먼저 항공 데이터가 어떻게 생성되는지를 살펴보고, 이어서 raw 데이터를 어떻게 정제하는지, 그리고 왜 시계열 분할이 중요한지와 temporal leakage 가 무엇인지를 다루겠습니다. 그다음으로 Feature Engineering 이 모델을 어떻게 바꾸는지를 실제 사례 R² 335 퍼센트 개선 사례로 보여드리고, 마지막으로 XGBoost 와 Isolation Forest 가 왜 선택됐는지 그 이유를 설명드립니다. 특히 세 번째와 네 번째가 가장 중요합니다. 이 두 가지는 실제로 제가 진행한 프로젝트의 P0, P1 스프린트에서 숫자로 증명된 내용이라, 숫자 자체를 꼭 기억해 두시면 좋겠습니다.</a:t>
             </a:r>
             <a:endParaRPr lang="en-US" dirty="0"/>
           </a:p>
@@ -1589,7 +1587,7 @@
           <a:p>
             <a:r>
               <a:rPr lang="en-US" dirty="0"/>
-              <a:t>우리가 만든 3 가지 기능. 각각 다른 데이터를 쓰는 것 같지만 공통 파이프라인에서 흘러나옵니다. 지연 예측은 Gold silver_flight_features, 이상 탐지는 Silver aircraft_phase, RAG 는 ChromaDB 161 chunks.</a:t>
+              <a:t>제가 직접 만든 세 가지 기능을 한 슬라이드에 모았습니다. 첫 번째는 지연 예측과 신뢰구간으로, XGBoost Test R² 0.43 에 Conformal 이 90 퍼센트 커버리지를 보장하며, 관제사는 '90 퍼센트 확률로 6 분에서 41 분 사이' 같은 정량적 정보를 받습니다. 두 번째는 비행 단계별 이상 탐지로, Isolation Forest 일곱 개를 운영해 alert fatigue 를 67 퍼센트 줄였습니다. 세 번째는 AI 관제 어시스턴트로, Qwen2.5-7B 를 QLoRA 와 DPO 로 직접 파인튜닝한 한국어 LLM 이고 RAG 로 161 개 chunks 규정집을 참조해 5 초 이내에 출처 포함 답변을 생성합니다. 세 기능이 독립적으로 보이지만 모두 같은 Iceberg 기반 데이터 파이프라인 위에 올라가 있습니다.</a:t>
             </a:r>
             <a:endParaRPr lang="en-US" dirty="0"/>
           </a:p>
@@ -1677,7 +1675,7 @@
           <a:p>
             <a:r>
               <a:rPr lang="en-US" dirty="0"/>
-              <a:t>XGBoost 는 2014 년 Tianqi Chen 이 발표한 이후 Kaggle 우승 모델의 사실상 표준입니다. 4 가지 이유 중 가장 실무에서 중요한 것은 3 번 '해석성' — 관제사에게 '왜 이 예측인가' 를 SHAP 으로 설명할 수 있기 때문입니다.</a:t>
+              <a:t>지연 예측 모델로 XGBoost 를 선택한 이유가 네 가지 있습니다. 첫째는 정확도로 tabular 데이터에서는 딥러닝과 동등하거나 더 낫고, 피처가 30 개 이하인 tabular 는 XGBoost 의 홈그라운드입니다. 둘째는 속도로 오백칠십만 행을 CPU 만으로 4 분 안에 학습할 수 있어 GPU 가 필요 없습니다. 셋째는 해석성으로 SHAP TreeExplainer 를 쓰면 피처별 기여도를 시각화해서 관제사에게 근거를 제시할 수 있고, 넷째는 robustness 로 결측값을 자동 처리하고 이상치에 강하며 normalization 이 필요 없습니다. 실무에서 가장 중요한 것은 세 번째 해석성입니다. 딥러닝 블랙박스로는 관제사의 '왜?' 에 납득할 만한 답을 줄 수 없습니다.</a:t>
             </a:r>
             <a:endParaRPr lang="en-US" dirty="0"/>
           </a:p>
@@ -1765,7 +1763,7 @@
           <a:p>
             <a:r>
               <a:rPr lang="en-US" dirty="0"/>
-              <a:t>Gradient Boosting 의 핵심 비유: 시험 공부할 때 '틀린 문제만 다시 보는 것' 과 같습니다. 첫 모델이 틀린 부분을 다음 모델이 집중 학습 → 그 다음 모델이 또 남은 오차를 학습 → 계속 개선. 200 개 트리의 합으로 강력한 앙상블이 됩니다.</a:t>
+              <a:t>XGBoost 는 여러 개의 약한 모델을 순차적으로 만들되, 이전 모델의 오차에만 집중해서 학습합니다. Tree 1 은 오차가 플러스마이너스 15 분 정도로 엉성하지만, Tree 2 가 남은 잔차에 집중해 플러스마이너스 8 분으로 줄이고, Tree 3 이 또 남은 오차에 집중해 플러스마이너스 3 분까지 내려옵니다. 이렇게 200 번까지 반복하면 최종 오차는 플러스마이너스 0.5 분 수준이 되고, 최종 예측은 Tree 1 부터 Tree 200 까지의 합이 됩니다. 시험 공부할 때 틀린 문제만 다시 보는 것과 같은 원리입니다. 70 퍼센트 맞추면 틀린 30 퍼센트만 집중하고, 그중 또 틀린 것만 집중하는 방식입니다. 이것이 gradient boosting 이라는 이름의 의미이고, 매 단계 손실 함수의 기울기를 따라 최적으로 수정해 나갑니다.</a:t>
             </a:r>
             <a:endParaRPr lang="en-US" dirty="0"/>
           </a:p>
@@ -1853,7 +1851,7 @@
           <a:p>
             <a:r>
               <a:rPr lang="en-US" dirty="0"/>
-              <a:t>세 개의 bar 가 모두 0.10 이고 마지막 두 개가 0.43 으로 뛰는 걸 보여주는 이유는 — TimeSeriesSplit (P0) 자체로는 수치가 안 올라갔다는 걸 보여주기 위해서입니다. 진짜 향상은 P1 의 Rotation features 5 개가 만들었습니다.</a:t>
+              <a:t>실제 제 프로젝트의 결과를 Sprint 별 Test R² 추이로 보여드립니다. 기본 XGBoost baseline 은 R² 0.10, TimeSeriesSplit 을 적용한 P0 도 R² 0.10 으로 수치는 그대로지만 정직해졌습니다. Rotation features 를 추가한 P1 에서 R² 가 0.43 으로 뛰었고, Conformal interval 을 붙인 P1+ 도 R² 0.43 을 유지하면서 예측 구간이 추가됐습니다. P0 에서 수치가 안 올라간 이유는 TimeSeriesSplit 이 더 좋은 모델을 만드는 게 아니라 더 정직한 평가를 해주는 기법이기 때문입니다. 진짜 향상은 P1 의 Rotation features 가 만들어냈습니다. 최종 지표는 Test RMSE 22.61 분, Test R² 0.43, Conformal coverage 정확히 90.00 퍼센트, p95 응답 시간 42 밀리세컨드입니다.</a:t>
             </a:r>
             <a:endParaRPr lang="en-US" dirty="0"/>
           </a:p>
@@ -1941,7 +1939,7 @@
           <a:p>
             <a:r>
               <a:rPr lang="en-US" dirty="0"/>
-              <a:t>항공 사고는 희귀해서 '정상 vs 사고' 라벨이 거의 없습니다. 이 상황에서 Autoencoder 를 쓰면 GPU 필요 + 학습 불안정. Isolation Forest 는 이 두 문제를 모두 해결합니다 — 라벨 불필요 + CPU 분 단위 학습 + 해석 가능.</a:t>
+              <a:t>두 번째 모델은 이상 탐지용 Isolation Forest 입니다. 핵심 아이디어는 이상치가 소수이고 정상과 거리가 멀기 때문에 무작위 분할로 빨리 고립된다는 점입니다. 정상점은 트리에서 깊이 내려가야 고립되어 path length 가 8 스플리츠 이상 필요한 반면, 이상점은 단 2 번에서 3 번의 분할로 곧바로 고립됩니다. 즉 path length 자체가 anomaly score 가 됩니다. 짧으면 이상, 길면 정상이라 매우 직관적입니다. Isolation Forest 를 선택한 이유는 항공 사고가 희귀해 라벨이 없기에 지도학습이 불가능하고, 빅오 엔 로그 엔 속도로 매우 빠르며, 해석이 직관적이기 때문입니다. Autoencoder 를 선택했다면 GPU 필요, 학습 불안정, 블랙박스 세 문제가 모두 생겼을 겁니다.</a:t>
             </a:r>
             <a:endParaRPr lang="en-US" dirty="0"/>
           </a:p>
@@ -2029,7 +2027,7 @@
           <a:p>
             <a:r>
               <a:rPr lang="en-US" dirty="0"/>
-              <a:t>단계별 모델은 7 배의 운영 비용이 들지만, alert fatigue 67% 감소라는 구체적 성과로 정당화됩니다. 각 phase 마다 contamination (이상 예상률) 을 도메인 지식으로 튜닝했습니다 — TAXI 는 조용한 구간이라 0.02, LANDING 은 사고 빈발 구간이라 0.06.</a:t>
+              <a:t>Isolation Forest 를 하나가 아니라 일곱 개 만든 이유는, 단일 모델이 비행 단계별 차이를 구분하지 못하기 때문입니다. CRUISE 중 3만 피트는 정상이지만 LANDING 중 3만 피트는 완전 비정상인데, 단일 모델은 이 둘을 구분 못하고 false positive 가 폭주하며 alert fatigue 를 유발합니다. 해결책으로 일곱 개의 비행 단계마다 별도 Isolation Forest 를 두고 contamination 을 개별 튜닝했습니다. TAXI 는 조용한 구간이라 0.02, TAKEOFF 0.03, CLIMB 0.04, CRUISE 0.05, DESCENT 0.04, APPROACH 와 LANDING 은 사고 빈발 구간이라 0.06 까지, TAXI 의 2 퍼센트부터 LANDING 의 6 퍼센트까지 3 배 차이로 튜닝했습니다. 결과적으로 False Positive 가 67 퍼센트 감소하며 alert fatigue 가 대폭 완화됐고, v2.1.10 과 ADR-006 에서 서빙에도 wire-up 이 완료됐습니다.</a:t>
             </a:r>
             <a:endParaRPr lang="en-US" dirty="0"/>
           </a:p>
@@ -2117,7 +2115,7 @@
           <a:p>
             <a:r>
               <a:rPr lang="en-US" dirty="0"/>
-              <a:t>Conformal Prediction 은 수학적으로 '90% 확률로 이 구간에 실제 값이 있다' 를 보장합니다. 분포 가정 없음 (distribution-free). MAPIE 라이브러리로 구현. 실측 coverage 가 정확히 90.00% 나온 것이 증거.</a:t>
+              <a:t>마지막 핵심 기법은 점 예측과 구간 예측의 차이입니다. '15 분 지연' 이라는 점 예측은 얼마나 믿어야 할지 알 수 없고, 실제로는 5 분일 수도 40 분일 수도 있습니다. 관제사가 이 숫자만 보고 승객 안내를 어떻게 하겠습니까. 근거 없는 high, medium, low confidence 분류로는 부족합니다. Conformal 을 적용한 후에는 '90 퍼센트 확률로 6 분에서 41 분 사이의 지연' 이라는 수학적으로 보장된 구간을 얻을 수 있고, 그것도 분포 가정 없이 보장됩니다. MAPIE 라이브러리로 구현했고 실측 coverage 가 정확히 90.00 퍼센트로 나온 것이 증거입니다. 이제 관제사는 최악의 경우 41 분까지 지연 가능하니 승객 안내를 준비하자는 정량적 의사결정을 할 수 있습니다.</a:t>
             </a:r>
             <a:endParaRPr lang="en-US" dirty="0"/>
           </a:p>
@@ -2205,7 +2203,7 @@
           <a:p>
             <a:r>
               <a:rPr lang="en-US" dirty="0"/>
-              <a:t>처음 ADS-B 전파부터 관제사 화면에 알림이 뜨기까지 전체 7 단계, p95 5 초 이내에 끝납니다. 각 단계의 지연: Kafka 100ms, Iceberg 조회 500ms, XGBoost 42ms, Conformal 100ms, LLM 2-3s, 나머지 network.</a:t>
+              <a:t>모든 조각을 하나로 연결해 보겠습니다. 비행기가 공중에 떠 있는 순간부터 관제사 화면에 알림이 뜨는 순간까지 일곱 단계가 5 초 이내에 흐릅니다. ADS-B 수신에서 비행기 위치가 OpenSky 로 오고, Kafka 의 flight-position 토픽에 Avro 메시지가 쌓입니다. Iceberg Silver 의 flight_features 에서 조인하고, XGBoost 가 42 밀리세컨드 안에 '지연 20 분' 을 예측합니다. Conformal 이 '90 퍼센트 확률로 12 분에서 40 분' 구간을 계산하고, RAG 와 LLM 이 FAA AIM 7-1 에 따른 출처 기반 조언을 생성해서 관제사 대시보드에 표시합니다. Kafka 약 100 밀리세컨드, Iceberg 500 밀리세컨드, XGBoost 42 밀리세컨드, Conformal 100 밀리세컨드, LLM 2 초에서 3 초가 걸리고, LLM 이 가장 느린 병목입니다.</a:t>
             </a:r>
             <a:endParaRPr lang="en-US" dirty="0"/>
           </a:p>
@@ -2293,7 +2291,7 @@
           <a:p>
             <a:r>
               <a:rPr lang="en-US" dirty="0"/>
-              <a:t>이 5 가지가 여러분이 이 발표에서 가져가야 할 전부입니다. 특히 2 번과 3 번은 실무에서 가장 많이 실수하는 부분이고, 우리 프로젝트의 P0/P1 sprint 가 그 증거입니다.</a:t>
+              <a:t>이 발표에서 여러분이 가져가셨으면 하는 다섯 가지 교훈입니다. 첫 번째, 데이터는 raw 단계에서 절대 완벽하지 않으니 cleaning 을 건너뛰지 마십시오. 두 번째, Feature Engineering 이 모델 크기보다 중요합니다. 제 프로젝트의 P1 에서 피처 다섯 개만 추가해 R² 가 335 퍼센트 개선됐습니다. 세 번째, 시계열 데이터는 절대 shuffle 하지 마십시오. temporal leakage 는 가장 흔하면서도 가장 치명적인 실수입니다. 네 번째, 모델 선택을 정확도만으로 하지 말고 해석성과 운영성, 유지 비용을 모두 고려하십시오. 다섯 번째, 도메인 지식이 곧 경쟁력입니다. EUROCONTROL 의 '지연 45 퍼센트는 reactionary 다' 라는 연구 한 줄이 Rotation features 설계의 씨앗이 됐습니다. 특히 두 번째와 세 번째가 초심자가 가장 많이 실패하는 지점입니다.</a:t>
             </a:r>
             <a:endParaRPr lang="en-US" dirty="0"/>
           </a:p>
@@ -2381,7 +2379,7 @@
           <a:p>
             <a:r>
               <a:rPr lang="en-US" dirty="0"/>
-              <a:t>예상 질문 5 개. 답변 요약: ① Iceberg = ACID + schema evolution + time-travel. plain parquet 에는 없음. ② Bayesian 은 prior 가정 필요, Conformal 은 분포 가정 없음. ③ 단일 모델은 contamination 을 균일하게 써야 해서 phase 별 3배 차이를 반영 못함. ④ 10% sampling 은 chronological 하게 뽑아서 시간 편향 없게 했음. ⑤ 161 chunks 는 RAGAs 평가에서 faithfulness 0.91 · context_precision 0.85 로 충분 검증됨.</a:t>
+              <a:t>예상 질문 다섯 개에 대한 답변을 준비해 왔습니다. 첫째, Iceberg 가 plain parquet 보다 나은 이유는 catalog, ACID 트랜잭션, 스키마 진화, time-travel 이 모두 포함된 테이블 포맷이기 때문입니다. 둘째, Bayesian 은 prior 가정이 필요하지만 Conformal 은 분포 가정 자체가 없어서 데이터가 가정을 어겨도 구간이 깨지지 않습니다. 셋째, 단일 모델은 contamination 을 모든 phase 에 동일하게 적용해야 해서 TAXI 2 퍼센트와 LANDING 6 퍼센트처럼 3 배 차이가 나는 phase 별 특성을 전혀 반영할 수 없습니다. 넷째, 10 퍼센트 샘플링은 chronological 하게 뽑아서 시간 편향이 없게 했고, 오십만 행이면 통계적으로 충분합니다. 다섯째, 161 chunks 는 RAGAs 평가에서 faithfulness 0.91, context_precision 0.85 로 검증됐고 국내선 관제에는 충분합니다.</a:t>
             </a:r>
             <a:endParaRPr lang="en-US" dirty="0"/>
           </a:p>
@@ -2469,7 +2467,7 @@
           <a:p>
             <a:r>
               <a:rPr lang="en-US" dirty="0"/>
-              <a:t>데이터는 항상 같은 흐름입니다 — 센서(측정) → 숫자(digitize) → 저장(storage) → 모델(model). 의료나 항공이나 본질은 같습니다. 이 4 단계를 계속 머릿속에 두세요.</a:t>
+              <a:t>잠깐 기본으로 돌아가 보겠습니다. 데이터란 무엇일까요. 한마디로 말씀드리면, 데이터는 세상의 측정값입니다. 의료에서는 체온계가 숫자를 만들고 EHR 데이터베이스를 거쳐 진단 모델로 흘러가고, 항공에서는 레이더 수신기가 위도와 경도를 측정해서 Kafka 스트림을 거쳐 지연 예측 모델로 들어갑니다. 센서, 숫자, 저장, 모델이라는 네 단계 구조는 어떤 도메인에서도 똑같이 반복됩니다. 이 프레임을 머릿속에 두시면, 앞으로 나올 모든 슬라이드가 이 구조 안에 들어맞게 됩니다.</a:t>
             </a:r>
             <a:endParaRPr lang="en-US" dirty="0"/>
           </a:p>
@@ -2557,8 +2555,7 @@
           <a:p>
             <a:r>
               <a:rPr lang="en-US" dirty="0"/>
-              <a:t>질문 받겠습니다. 감사합니다.
-Thank you. Questions?</a:t>
+              <a:t>오늘 발표의 핵심 세 가지를 다시 정리드립니다. 첫째, 데이터는 전처리가 핵심이니 여섯 단계 파이프라인을 기억해 주시기 바랍니다. 둘째, Feature Engineering 이 모델보다 강력하며 335 퍼센트 개선 사례가 그 증거입니다. 셋째, 시계열 데이터는 절대 shuffle 하지 마시고, ADR-004 의 원칙을 참고해 주세요. 질문이 더 있으시면 발표 후에도 편하게 말씀해 주세요. 감사합니다.</a:t>
             </a:r>
             <a:endParaRPr lang="en-US" dirty="0"/>
           </a:p>
@@ -2646,7 +2643,7 @@
           <a:p>
             <a:r>
               <a:rPr lang="en-US" dirty="0"/>
-              <a:t>이 네 가지 특성이 왜 '아무 데이터나 쓰면 안 되는가' 를 설명합니다. 실시간 · 고빈도 → Kafka 가 필요. 시계열 → shuffle 금지 (슬라이드 17). 다중 소스 → Schema Registry 필요 (슬라이드 11).</a:t>
+              <a:t>항공 데이터에는 네 가지 특별한 성질이 있습니다. 첫째는 실시간 성질로 초 단위로 업데이트되기 때문에 1 분의 지연도 큰 의미를 갖고, 둘째는 고빈도 성질로 초당 수천 건이 쏟아져 들어옵니다. 셋째는 시계열 성질인데 순서가 매우 중요해서 절대로 섞으면 안 되고, 넷째는 다중 소스 성질로 레이더와 기상, 관제 메시지가 모두 합쳐져야 비로소 의미가 생깁니다. 이 네 가지 성질이 바로 아무 데이터나 아무 방식으로 쓰면 안 되는 이유입니다. 실시간과 고빈도 때문에 Kafka 가 필요하고, 시계열이기 때문에 절대 shuffle 을 하면 안 되며, 다중 소스이기 때문에 Schema Registry 라는 계약이 필요합니다.</a:t>
             </a:r>
             <a:endParaRPr lang="en-US" dirty="0"/>
           </a:p>
@@ -2734,7 +2731,7 @@
           <a:p>
             <a:r>
               <a:rPr lang="en-US" dirty="0"/>
-              <a:t>4 개 소스 중 3 번 FAA SWIM 이 가장 도전적이었고 가장 자랑스러운 성과입니다. 나머지는 쉽게 접근 가능한 공개 데이터지만 SWIM 은 공식 구독 + TLS 인증서 + AIXM XML 파서가 모두 필요합니다.</a:t>
+              <a:t>저는 이 프로젝트에서 총 네 가지 데이터 소스를 사용하고 있습니다. 첫 번째는 OpenSky Network 로 전 세계 3만 5천 개 지상 수신기가 기여하는 공개 ADS-B 네트워크이고 10 초마다 항공기 위치가 업데이트됩니다. 두 번째는 NOAA 와 KMA 의 METAR 데이터로 공항 기상 보고서이고 30 분 주기로 갱신되며, 세 번째가 FAA SWIM 으로 미 연방항공청의 공식 System Wide Information Management 데이터입니다. 네 번째는 Kaggle 의 flights.csv 로 오백칠십만 행 규모의 2015 년 배치 데이터입니다. 별표가 붙은 SWIM 은 제가 이 프로젝트에서 가장 자랑스럽게 생각하는 플래그십 성과입니다.</a:t>
             </a:r>
             <a:endParaRPr lang="en-US" dirty="0"/>
           </a:p>
@@ -2822,7 +2819,7 @@
           <a:p>
             <a:r>
               <a:rPr lang="en-US" dirty="0"/>
-              <a:t>ADS-B 는 자동차의 블랙박스처럼 비행기가 스스로 자기 위치를 방송하는 시스템입니다. 방송 → 땅의 수신기가 받음 → OpenSky 서버가 집계 → 우리가 API 로 받음. 항공기 한 대당 17 개 필드가 10 초마다 들어옵니다.</a:t>
+              <a:t>ADS-B 는 Automatic Dependent Surveillance-Broadcast 의 약자입니다. 항공기가 자기 위치를 스스로 방송하면 지상 수신기가 받아서 OpenSky 서버의 API 로 전송합니다. 제가 작성한 수집기가 30 초마다 OpenSky API 를 폴링해서 Kafka 의 flight-position 토픽으로 publish 하도록 구현했습니다. 항공기 한 편당 업데이트마다 17 개 필드가 들어오고, 전 세계 3만 5천 대의 수신기가 대부분 자원봉사자에 의해 운영됩니다.</a:t>
             </a:r>
             <a:endParaRPr lang="en-US" dirty="0"/>
           </a:p>
@@ -2910,7 +2907,7 @@
           <a:p>
             <a:r>
               <a:rPr lang="en-US" dirty="0"/>
-              <a:t>METAR 는 항공 기상의 국제 표준 포맷입니다. 겉보기엔 암호 같지만 토큰 하나하나가 정확한 의미를 가집니다. 우리 코드는 이걸 파싱해서 JSON → Avro 로 변환해 Kafka 에 publish 합니다.</a:t>
+              <a:t>두 번째 소스인 METAR 기상 보고서는 처음 보면 암호처럼 보이지만 함께 해독해 보면 어렵지 않습니다. 한 줄의 METAR 가 일곱 개의 토큰으로 분해되는데, RKSI 는 인천공항 ICAO 코드, 030900Z 는 3 일 09 시 UTC 관측, 29012KT 는 풍향 290 도 풍속 12 노트, 9999 는 가시거리 10 킬로미터 이상, SCT030 은 3000 피트에 부분운, 08/M02 는 기온 8 도 이슬점 영하 2 도, Q1020 은 QNH 1020 헥토파스칼을 뜻합니다. 이 포맷은 국제 항공 표준이라 전 세계가 공통으로 사용하고, 제가 작성한 파서가 이 문자열을 JSON 으로 파싱하고 다시 Avro 로 변환해 Kafka 에 넣습니다.</a:t>
             </a:r>
             <a:endParaRPr lang="en-US" dirty="0"/>
           </a:p>
@@ -2998,7 +2995,7 @@
           <a:p>
             <a:r>
               <a:rPr lang="en-US" dirty="0"/>
-              <a:t>대학 캡스톤으로는 드물게 FAA 프로덕션 브로커에 직접 연결했습니다. 219 건을 60 초 안에 파싱 에러 0 으로 받은 로그가 증거입니다. 이게 가능했던 이유는 trust store 설정을 포기하지 않고 세 번 다시 했기 때문입니다.</a:t>
+              <a:t>이 프로젝트에서 제가 가장 자랑스럽게 생각하는 플래그십 성과라 슬라이드 한 장을 통째로 썼습니다. 미 연방항공청의 프로덕션 브로커에 직접 연결해서 60 초 안에 실제 NOTAM 219 건을 파싱 에러 0 건으로 수신했습니다. 대학 캡스톤 프로젝트로서는 극히 드문 성과인데, 일반 REST API 가 아니라 Solace JMS 프로토콜을 써야 하고, TLS 1.2 인증서 검증이 필수이며, AIXM 5.1 표준 XML 파서를 직접 구현해야 했기 때문입니다. trust store 셋업을 세 번 연속 실패하고 네 번째에 성공했고, DigiCert Global Root G2 인증서를 수동으로 c_rehash 형식으로 import 하고 나서야 해결할 수 있었습니다. 학부생 신분으로도 이런 인프라 수준의 integration 에 도전할 수 있다는 것을 보여드리고 싶어 실패 과정까지 공유드렸습니다.</a:t>
             </a:r>
             <a:endParaRPr lang="en-US" dirty="0"/>
           </a:p>
@@ -3086,7 +3083,7 @@
           <a:p>
             <a:r>
               <a:rPr lang="en-US" dirty="0"/>
-              <a:t>EDA (Exploratory Data Analysis) 단계에서 가장 중요한 발견: 지연의 40% 가 '전편 지연' 에서 온다는 것. 이게 P1 sprint 에서 rotation features 5 개를 추가하게 된 도메인 근거가 되었고, Test R² 를 3.35 배 올려줬습니다.</a:t>
+              <a:t>네 번째 소스인 Kaggle 데이터는 배치 데이터로 오백칠십만 행 곱하기 31 컬럼, 용량은 580 메가바이트입니다. 지연된 편이 전체의 38.8 퍼센트, 취소가 3.4 퍼센트, 평균 도착 지연이 6.2 분이고, 최대 지연은 무려 천구백칠십일 분, 즉 약 32 시간입니다. 특히 중요한 발견은 전체 지연의 39.6 퍼센트가 '전편 지연' 즉 cascade 또는 reactionary 딜레이에서 발생한다는 점입니다. 이 40 퍼센트라는 숫자가 뒤에 나올 Rotation features 의 도메인 근거가 되니 꼭 기억해 주시기 바랍니다.</a:t>
             </a:r>
             <a:endParaRPr lang="en-US" dirty="0"/>
           </a:p>
@@ -13279,7 +13276,7 @@
                 <a:ea typeface="Malgun Gothic" pitchFamily="34" charset="-122"/>
                 <a:cs typeface="Malgun Gothic" pitchFamily="34" charset="-120"/>
               </a:rPr>
-              <a:t>💡 우리 프로젝트: </a:t>
+              <a:t>💡 제 프로젝트: </a:t>
             </a:r>
             <a:pPr indent="0" marL="0">
               <a:buNone/>
@@ -23003,7 +23000,7 @@
                 <a:ea typeface="Malgun Gothic" pitchFamily="34" charset="-122"/>
                 <a:cs typeface="Malgun Gothic" pitchFamily="34" charset="-120"/>
               </a:rPr>
-              <a:t>우리가 만든 것</a:t>
+              <a:t>제가 만든 것</a:t>
             </a:r>
             <a:endParaRPr lang="en-US" sz="2200" dirty="0"/>
           </a:p>
@@ -23042,7 +23039,7 @@
                 <a:ea typeface="Malgun Gothic" pitchFamily="34" charset="-122"/>
                 <a:cs typeface="Malgun Gothic" pitchFamily="34" charset="-120"/>
               </a:rPr>
-              <a:t>What WE built — three integrated features</a:t>
+              <a:t>3 integrated features on one pipeline</a:t>
             </a:r>
             <a:endParaRPr lang="en-US" sz="1050" dirty="0"/>
           </a:p>

</xml_diff>